<commit_message>
Define 'cold referral' on team-deck slide 3 and in glossary
Co-Authored-By: Claude Fable 5 <noreply@anthropic.com>
Claude-Session: https://claude.ai/code/session_01Ei2NMkxuP1dquQsjedq4wC
</commit_message>
<xml_diff>
--- a/pm/kristen-share/SHP-Spine-Team-Rollout_Kristen_Jul22.pptx
+++ b/pm/kristen-share/SHP-Spine-Team-Rollout_Kristen_Jul22.pptx
@@ -7155,7 +7155,7 @@
                 <a:ea typeface="Calibri" pitchFamily="34" charset="-122"/>
                 <a:cs typeface="Calibri" pitchFamily="34" charset="-120"/>
               </a:rPr>
-              <a:t>PATIENTS ARRIVED 'COLD'</a:t>
+              <a:t>'COLD' = NO PRIOR VISIT</a:t>
             </a:r>
             <a:endParaRPr lang="en-US" sz="1100" dirty="0"/>
           </a:p>
@@ -7194,7 +7194,7 @@
                 <a:ea typeface="Calibri" pitchFamily="34" charset="-122"/>
                 <a:cs typeface="Calibri" pitchFamily="34" charset="-120"/>
               </a:rPr>
-              <a:t>Virtually every referral followed a field visit. Your windshield time IS the pipeline.</a:t>
+              <a:t>Only 6 matched referrals came from a practice we'd never visited. Virtually every referral followed field contact - your windshield time IS the pipeline.</a:t>
             </a:r>
             <a:endParaRPr lang="en-US" sz="1100" dirty="0"/>
           </a:p>

</xml_diff>

<commit_message>
Adopt Kristen's relaxed visit cadence across schedule, app, decks, MMC sync
Cadence per the Jul 22 review: Wave 1 <=14d (biweekly) · Tier 1 21d ·
Tier 2 30d · Tier 3 45d · prospects 45d first pass. Scheduler rebuilt with
per-class due logic (disjoint classes; achieved medians exactly on spec:
W1 2.0wk / T1 3.0wk / T2 4.0wk); every proven-spine account guaranteed
coverage (forced sweeps); all 36 lapsed repeats still visited by W2.
Schedule now 1,126 stops; backlog 323 accounts (prospects + cross-sell
only). Honest trade recorded: honoring T2's 30-day rhythm costs ~35
prospect first-touches (234 of 466 by Oct 2). App, MMC import frequencies
(21/30/45 groups), plan memo, glossary, and both decks updated.

Co-Authored-By: Claude Fable 5 <noreply@anthropic.com>
Claude-Session: https://claude.ai/code/session_01Ei2NMkxuP1dquQsjedq4wC
</commit_message>
<xml_diff>
--- a/pm/kristen-share/SHP-Spine-Team-Rollout_Kristen_Jul22.pptx
+++ b/pm/kristen-share/SHP-Spine-Team-Rollout_Kristen_Jul22.pptx
@@ -7221,7 +7221,7 @@
                           <a:ea typeface="Calibri" pitchFamily="34" charset="-122"/>
                           <a:cs typeface="Calibri" pitchFamily="34" charset="-120"/>
                         </a:rPr>
-                        <a:t>every 14 days</a:t>
+                        <a:t>every 21 days</a:t>
                       </a:r>
                       <a:endParaRPr lang="en-US" sz="1300" dirty="0">
                         <a:latin typeface="Calibri" charset="0"/>
@@ -7483,7 +7483,7 @@
                           <a:ea typeface="Calibri" pitchFamily="34" charset="-122"/>
                           <a:cs typeface="Calibri" pitchFamily="34" charset="-120"/>
                         </a:rPr>
-                        <a:t>every 21 days</a:t>
+                        <a:t>every 30 days</a:t>
                       </a:r>
                       <a:endParaRPr lang="en-US" sz="1300" dirty="0">
                         <a:latin typeface="Calibri" charset="0"/>
@@ -7745,7 +7745,7 @@
                           <a:ea typeface="Calibri" pitchFamily="34" charset="-122"/>
                           <a:cs typeface="Calibri" pitchFamily="34" charset="-120"/>
                         </a:rPr>
-                        <a:t>every 30 days</a:t>
+                        <a:t>every 45 days</a:t>
                       </a:r>
                       <a:endParaRPr lang="en-US" sz="1300" dirty="0">
                         <a:latin typeface="Calibri" charset="0"/>
@@ -8269,7 +8269,7 @@
                           <a:ea typeface="Calibri" pitchFamily="34" charset="-122"/>
                           <a:cs typeface="Calibri" pitchFamily="34" charset="-120"/>
                         </a:rPr>
-                        <a:t>tightest</a:t>
+                        <a:t>≤ 14 days</a:t>
                       </a:r>
                       <a:endParaRPr lang="en-US" sz="1300" dirty="0">
                         <a:latin typeface="Calibri" charset="0"/>

</xml_diff>

<commit_message>
Live review round 2: handful ask, all-in on ortho, promote/hold/park replaces drop rule
- Prospect ask everywhere (deck, playbook, all 611 per-account messages,
  app): 'Send us a handful - let us show you what we're about'
- Ortho cross-sell: removed 'don't over-invest until they test us';
  now explicitly all-in (and 21d corrected to 30d rhythm on the script)
- Drop rule replaced with the 90-day read: nothing deleted; at ~2 touches
  the PL's field read decides promote (hit more often) / hold / park to
  backlog; per-touch notes power the call. Plan memo rule row updated.

Co-Authored-By: Claude Fable 5 <noreply@anthropic.com>
Claude-Session: https://claude.ai/code/session_01Ei2NMkxuP1dquQsjedq4wC
</commit_message>
<xml_diff>
--- a/pm/kristen-share/SHP-Spine-Team-Rollout_Kristen_Jul22.pptx
+++ b/pm/kristen-share/SHP-Spine-Team-Rollout_Kristen_Jul22.pptx
@@ -1571,7 +1571,7 @@
           <a:p>
             <a:r>
               <a:rPr lang="en-US" dirty="0"/>
-              <a:t>Give the team explicit permission to drop - guilt-visiting dead accounts is where field time goes to die.</a:t>
+              <a:t>Frame: promote/hold/park. The note after each touch is what powers the 90-day read - that is the answer to how we assess vibes.</a:t>
             </a:r>
             <a:endParaRPr lang="en-US" dirty="0"/>
           </a:p>
@@ -9964,7 +9964,7 @@
                 <a:ea typeface="Calibri" pitchFamily="34" charset="-122"/>
                 <a:cs typeface="Calibri" pitchFamily="34" charset="-120"/>
               </a:rPr>
-              <a:t>These are Tier 2 — 21-day rhythm, don't over-invest until they test us.</a:t>
+              <a:t>These are Tier 2 — 30-day rhythm, and we are ALL-IN on them: they already trust us with patients.</a:t>
             </a:r>
             <a:endParaRPr lang="en-US" sz="1250" dirty="0"/>
           </a:p>
@@ -10028,7 +10028,7 @@
                 <a:ea typeface="Cambria" pitchFamily="34" charset="-122"/>
                 <a:cs typeface="Cambria" pitchFamily="34" charset="-120"/>
               </a:rPr>
-              <a:t>Say this: prospects (FIRST TOUCH) — and when to stop</a:t>
+              <a:t>Say this: prospects — and the 90-day read</a:t>
             </a:r>
             <a:endParaRPr lang="en-US" sz="2900" dirty="0"/>
           </a:p>
@@ -10067,7 +10067,7 @@
                 <a:ea typeface="Calibri" pitchFamily="34" charset="-122"/>
                 <a:cs typeface="Calibri" pitchFamily="34" charset="-120"/>
               </a:rPr>
-              <a:t>469 accounts, pre-mixed into your route days. Test cheaply, drop honestly.</a:t>
+              <a:t>469 accounts, pre-mixed into your route days. Nothing gets deleted — your field read decides what moves up.</a:t>
             </a:r>
             <a:endParaRPr lang="en-US" sz="1300" dirty="0"/>
           </a:p>
@@ -10133,7 +10133,7 @@
                 <a:ea typeface="Cambria" pitchFamily="34" charset="-122"/>
                 <a:cs typeface="Cambria" pitchFamily="34" charset="-120"/>
               </a:rPr>
-              <a:t>Prospect first touch — earn one referral</a:t>
+              <a:t>Prospect first touch — earn the first handful</a:t>
             </a:r>
             <a:endParaRPr lang="en-US" sz="1500" dirty="0"/>
           </a:p>
@@ -10233,7 +10233,7 @@
                 <a:ea typeface="Calibri" pitchFamily="34" charset="-122"/>
                 <a:cs typeface="Calibri" pitchFamily="34" charset="-120"/>
               </a:rPr>
-              <a:t>ASK: “One referral to prove the pathway.” Leave one-pager + direct line. Log who you met — next time you greet them by name.</a:t>
+              <a:t>ASK: “Send us a handful — let us show you what we're about.” Leave one-pager + direct line. Log who you met — next time you greet them by name.</a:t>
             </a:r>
             <a:endParaRPr lang="en-US" sz="1250" dirty="0"/>
           </a:p>
@@ -10294,7 +10294,7 @@
                 <a:ea typeface="Calibri" pitchFamily="34" charset="-122"/>
                 <a:cs typeface="Calibri" pitchFamily="34" charset="-120"/>
               </a:rPr>
-              <a:t>THE DROP RULE</a:t>
+              <a:t>THE 90-DAY READ</a:t>
             </a:r>
             <a:endParaRPr lang="en-US" sz="1400" dirty="0"/>
           </a:p>
@@ -10309,7 +10309,7 @@
         <p:spPr>
           <a:xfrm>
             <a:off x="7726680" y="2148840"/>
-            <a:ext cx="3657600" cy="3566160"/>
+            <a:ext cx="3657600" cy="3657600"/>
           </a:xfrm>
           <a:prstGeom prst="rect">
             <a:avLst/>
@@ -10323,12 +10323,12 @@
           <a:p>
             <a:pPr indent="0" marL="0">
               <a:lnSpc>
-                <a:spcPct val="125000"/>
+                <a:spcPct val="118000"/>
               </a:lnSpc>
               <a:buNone/>
             </a:pPr>
             <a:r>
-              <a:rPr lang="en-US" sz="1250" dirty="0">
+              <a:rPr lang="en-US" sz="1150" dirty="0">
                 <a:solidFill>
                   <a:srgbClr val="E4EFEC"/>
                 </a:solidFill>
@@ -10336,28 +10336,28 @@
                 <a:ea typeface="Calibri" pitchFamily="34" charset="-122"/>
                 <a:cs typeface="Calibri" pitchFamily="34" charset="-120"/>
               </a:rPr>
-              <a:t>A prospect that produces nothing after 2 real touches comes OUT of rotation — the backlog has 200 more waiting.</a:t>
-            </a:r>
-            <a:endParaRPr lang="en-US" sz="1250" dirty="0"/>
+              <a:t>Nothing gets deleted — every account stays on the list. After ~2 touches (about 90 days at prospect rhythm), YOUR read decides:</a:t>
+            </a:r>
+            <a:endParaRPr lang="en-US" sz="1150" dirty="0"/>
           </a:p>
           <a:p>
             <a:pPr indent="0" marL="0">
               <a:lnSpc>
-                <a:spcPct val="125000"/>
+                <a:spcPct val="118000"/>
               </a:lnSpc>
               <a:buNone/>
             </a:pPr>
-            <a:endParaRPr lang="en-US" sz="1250" dirty="0"/>
+            <a:endParaRPr lang="en-US" sz="1150" dirty="0"/>
           </a:p>
           <a:p>
             <a:pPr indent="0" marL="0">
               <a:lnSpc>
-                <a:spcPct val="125000"/>
+                <a:spcPct val="118000"/>
               </a:lnSpc>
               <a:buNone/>
             </a:pPr>
             <a:r>
-              <a:rPr lang="en-US" sz="1250" dirty="0">
+              <a:rPr lang="en-US" sz="1150" dirty="0">
                 <a:solidFill>
                   <a:srgbClr val="E4EFEC"/>
                 </a:solidFill>
@@ -10365,28 +10365,28 @@
                 <a:ea typeface="Calibri" pitchFamily="34" charset="-122"/>
                 <a:cs typeface="Calibri" pitchFamily="34" charset="-120"/>
               </a:rPr>
-              <a:t>A Tier 3 account at zero after 2 cycles: same.</a:t>
-            </a:r>
-            <a:endParaRPr lang="en-US" sz="1250" dirty="0"/>
+              <a:t>PROMOTE — real potential? Move it up, hit it more often.</a:t>
+            </a:r>
+            <a:endParaRPr lang="en-US" sz="1150" dirty="0"/>
           </a:p>
           <a:p>
             <a:pPr indent="0" marL="0">
               <a:lnSpc>
-                <a:spcPct val="125000"/>
+                <a:spcPct val="118000"/>
               </a:lnSpc>
               <a:buNone/>
             </a:pPr>
-            <a:endParaRPr lang="en-US" sz="1250" dirty="0"/>
+            <a:endParaRPr lang="en-US" sz="1150" dirty="0"/>
           </a:p>
           <a:p>
             <a:pPr indent="0" marL="0">
               <a:lnSpc>
-                <a:spcPct val="125000"/>
+                <a:spcPct val="118000"/>
               </a:lnSpc>
               <a:buNone/>
             </a:pPr>
             <a:r>
-              <a:rPr lang="en-US" sz="1250" dirty="0">
+              <a:rPr lang="en-US" sz="1150" dirty="0">
                 <a:solidFill>
                   <a:srgbClr val="E4EFEC"/>
                 </a:solidFill>
@@ -10394,9 +10394,67 @@
                 <a:ea typeface="Calibri" pitchFamily="34" charset="-122"/>
                 <a:cs typeface="Calibri" pitchFamily="34" charset="-120"/>
               </a:rPr>
-              <a:t>Dropping is not failure; it's how the rotation keeps earning its gas money.</a:t>
-            </a:r>
-            <a:endParaRPr lang="en-US" sz="1250" dirty="0"/>
+              <a:t>HOLD — keep the 45-day rhythm.</a:t>
+            </a:r>
+            <a:endParaRPr lang="en-US" sz="1150" dirty="0"/>
+          </a:p>
+          <a:p>
+            <a:pPr indent="0" marL="0">
+              <a:lnSpc>
+                <a:spcPct val="118000"/>
+              </a:lnSpc>
+              <a:buNone/>
+            </a:pPr>
+            <a:endParaRPr lang="en-US" sz="1150" dirty="0"/>
+          </a:p>
+          <a:p>
+            <a:pPr indent="0" marL="0">
+              <a:lnSpc>
+                <a:spcPct val="118000"/>
+              </a:lnSpc>
+              <a:buNone/>
+            </a:pPr>
+            <a:r>
+              <a:rPr lang="en-US" sz="1150" dirty="0">
+                <a:solidFill>
+                  <a:srgbClr val="E4EFEC"/>
+                </a:solidFill>
+                <a:latin typeface="Calibri" pitchFamily="34" charset="0"/>
+                <a:ea typeface="Calibri" pitchFamily="34" charset="-122"/>
+                <a:cs typeface="Calibri" pitchFamily="34" charset="-120"/>
+              </a:rPr>
+              <a:t>PARK — no signal? Backlog it and give that road time to the next prospect; revisit next quarter.</a:t>
+            </a:r>
+            <a:endParaRPr lang="en-US" sz="1150" dirty="0"/>
+          </a:p>
+          <a:p>
+            <a:pPr indent="0" marL="0">
+              <a:lnSpc>
+                <a:spcPct val="118000"/>
+              </a:lnSpc>
+              <a:buNone/>
+            </a:pPr>
+            <a:endParaRPr lang="en-US" sz="1150" dirty="0"/>
+          </a:p>
+          <a:p>
+            <a:pPr indent="0" marL="0">
+              <a:lnSpc>
+                <a:spcPct val="118000"/>
+              </a:lnSpc>
+              <a:buNone/>
+            </a:pPr>
+            <a:r>
+              <a:rPr lang="en-US" sz="1150" dirty="0">
+                <a:solidFill>
+                  <a:srgbClr val="E4EFEC"/>
+                </a:solidFill>
+                <a:latin typeface="Calibri" pitchFamily="34" charset="0"/>
+                <a:ea typeface="Calibri" pitchFamily="34" charset="-122"/>
+                <a:cs typeface="Calibri" pitchFamily="34" charset="-120"/>
+              </a:rPr>
+              <a:t>Your one-line note after each touch is what makes this call possible.</a:t>
+            </a:r>
+            <a:endParaRPr lang="en-US" sz="1150" dirty="0"/>
           </a:p>
         </p:txBody>
       </p:sp>

</xml_diff>